<commit_message>
Banking-app UI: cards, portfolio hero, asset ring, list rows, messenger chat
Grey canvas with white rounded cards and one navy primary action.
Profile: questions as cards with numbered progress and a sticky submit
bar; the result leads once assessed. Portfolio: balance-style hero, KPI
tiles, asset-mix ring and holdings as list rows with asset icons. On
phones the chat opens full screen from the top bar, new advisor
messages show as a preview with an unread count, and the next step sits
in a sticky bottom bar. Docs screenshots, deck and PDFs rebuilt.

Co-Authored-By: Claude Opus 5.5 (1M context) <noreply@anthropic.com>
</commit_message>
<xml_diff>
--- a/submission/Keel_FinTechathon_2026.pptx
+++ b/submission/Keel_FinTechathon_2026.pptx
@@ -118,27 +118,27 @@
   <p:extLst>
     <p:ext uri="{521415D9-36F7-43E2-AB2F-B90AF26B5E84}">
       <p14:sectionLst xmlns:p14="http://schemas.microsoft.com/office/powerpoint/2010/main">
-        <p14:section name="The problem" id="{811f60ca-93eb-6357-3099-25bacc7e298c}">
+        <p14:section name="The problem" id="{ad527052-611d-b623-c5b0-c00e66b7ca1c}">
           <p14:sldIdLst>
             <p14:sldId id="256"/>
             <p14:sldId id="257"/>
           </p14:sldIdLst>
         </p14:section>
-        <p14:section name="Keel" id="{088f20d2-fdfb-898f-74d0-c7d71e011560}">
+        <p14:section name="Keel" id="{dd3c8667-1fe6-8f70-703b-b83c63933ad7}">
           <p14:sldIdLst>
             <p14:sldId id="258"/>
             <p14:sldId id="259"/>
             <p14:sldId id="260"/>
           </p14:sldIdLst>
         </p14:section>
-        <p14:section name="Proof" id="{daa3406c-36f9-ad4d-25a0-876ba57f1f5d}">
+        <p14:section name="Proof" id="{c65dab65-69dd-94c5-3d73-f90d6e65c62b}">
           <p14:sldIdLst>
             <p14:sldId id="261"/>
             <p14:sldId id="262"/>
             <p14:sldId id="263"/>
           </p14:sldIdLst>
         </p14:section>
-        <p14:section name="Results and fit" id="{245c2944-443e-6e83-5ec7-edfb7422ce92}">
+        <p14:section name="Results and fit" id="{0cc4b236-e712-c08b-3000-0777d60d8e49}">
           <p14:sldIdLst>
             <p14:sldId id="264"/>
             <p14:sldId id="265"/>
@@ -1518,7 +1518,7 @@
           <a:p>
             <a:r>
               <a:rPr lang="en-US" dirty="0"/>
-              <a:t>Here is what we measured. Twenty-nine of thirty scripted clients completed the whole journey on a live model. All 57 red-team attacks were stopped. 129 automated tests run offline in continuous integration. And a backtest from 2008 to 2026: every risk class stayed inside its volatility band, yet every one fell further than that number suggests; C5 lost 34 percent in 2008. That is exactly why Keel enforces the client's own loss limit and makes them rehearse the crash.</a:t>
+              <a:t>Here is what we measured. Twenty-nine of thirty scripted clients completed the whole journey on a live model. All 57 red-team attacks were stopped. 132 automated tests run offline in continuous integration. And a backtest from 2008 to 2026: every risk class stayed inside its volatility band, yet every one fell further than that number suggests; C5 lost 34 percent in 2008. That is exactly why Keel enforces the client's own loss limit and makes them rehearse the crash.</a:t>
             </a:r>
             <a:endParaRPr lang="en-US" dirty="0"/>
           </a:p>
@@ -10424,7 +10424,7 @@
                 <a:ea typeface="Arial" pitchFamily="34" charset="-122"/>
                 <a:cs typeface="Arial" pitchFamily="34" charset="-120"/>
               </a:rPr>
-              <a:t>129</a:t>
+              <a:t>132</a:t>
             </a:r>
             <a:endParaRPr lang="en-US" sz="4000" dirty="0"/>
           </a:p>

</xml_diff>